<commit_message>
System Design vi: sd-14-019 deck updated for the signed-JWT scope and issuer/audience check
Co-Authored-By: Claude Sonnet 5.5 <noreply@anthropic.com>
Claude-Session: https://claude.ai/code/session_01WnjciXNJBLEd8jy3HrG49S
</commit_message>
<xml_diff>
--- a/system-design-101/vi/lessons/sd-14-019/slides/sd-14-019.pptx
+++ b/system-design-101/vi/lessons/sd-14-019/slides/sd-14-019.pptx
@@ -3807,8 +3807,8 @@
         </p:nvSpPr>
         <p:spPr>
           <a:xfrm>
-            <a:off x="1257300" y="5067300"/>
-            <a:ext cx="4667250" cy="914400"/>
+            <a:off x="1257300" y="4762500"/>
+            <a:ext cx="4667250" cy="1276350"/>
           </a:xfrm>
           <a:prstGeom prst="rect">
             <a:avLst/>
@@ -3910,10 +3910,10 @@
                 <a:ea typeface="Be Vietnam Pro" pitchFamily="34" charset="-122"/>
                 <a:cs typeface="Be Vietnam Pro" pitchFamily="34" charset="-120"/>
               </a:rPr>
-              <a:t> dùng</a:t>
-            </a:r>
-            <a:r>
-              <a:rPr lang="en-US" sz="2400" dirty="0" spc="-15" kern="0">
+              <a:t> dùng,</a:t>
+            </a:r>
+            <a:r>
+              <a:rPr lang="en-US" sz="2400" dirty="0" spc="2" kern="0">
                 <a:solidFill>
                   <a:srgbClr val="D8D3C4"/>
                 </a:solidFill>
@@ -3921,10 +3921,10 @@
                 <a:ea typeface="Be Vietnam Pro" pitchFamily="34" charset="-122"/>
                 <a:cs typeface="Be Vietnam Pro" pitchFamily="34" charset="-120"/>
               </a:rPr>
-              <a:t> và</a:t>
-            </a:r>
-            <a:r>
-              <a:rPr lang="en-US" sz="2400" dirty="0" spc="0" kern="0">
+              <a:t> ở</a:t>
+            </a:r>
+            <a:r>
+              <a:rPr lang="en-US" sz="2400" dirty="0" spc="3" kern="0">
                 <a:solidFill>
                   <a:srgbClr val="D8D3C4"/>
                 </a:solidFill>
@@ -3932,10 +3932,10 @@
                 <a:ea typeface="Be Vietnam Pro" pitchFamily="34" charset="-122"/>
                 <a:cs typeface="Be Vietnam Pro" pitchFamily="34" charset="-120"/>
               </a:rPr>
-              <a:t> có</a:t>
-            </a:r>
-            <a:r>
-              <a:rPr lang="en-US" sz="2400" dirty="0" spc="1" kern="0">
+              <a:t> dạng</a:t>
+            </a:r>
+            <a:r>
+              <a:rPr lang="en-US" sz="2400" dirty="0" spc="-1" kern="0">
                 <a:solidFill>
                   <a:srgbClr val="D8D3C4"/>
                 </a:solidFill>
@@ -3943,10 +3943,19 @@
                 <a:ea typeface="Be Vietnam Pro" pitchFamily="34" charset="-122"/>
                 <a:cs typeface="Be Vietnam Pro" pitchFamily="34" charset="-120"/>
               </a:rPr>
-              <a:t> chữ</a:t>
-            </a:r>
-            <a:r>
-              <a:rPr lang="en-US" sz="2400" dirty="0" spc="-1" kern="0">
+              <a:t> ký</a:t>
+            </a:r>
+            <a:endParaRPr lang="en-US" sz="2400" dirty="0"/>
+          </a:p>
+          <a:p>
+            <a:pPr algn="l" indent="0" marL="0">
+              <a:lnSpc>
+                <a:spcPts val="3240"/>
+              </a:lnSpc>
+              <a:buNone/>
+            </a:pPr>
+            <a:r>
+              <a:rPr lang="en-US" sz="2400" dirty="0" spc="2" kern="0">
                 <a:solidFill>
                   <a:srgbClr val="D8D3C4"/>
                 </a:solidFill>
@@ -3954,7 +3963,18 @@
                 <a:ea typeface="Be Vietnam Pro" pitchFamily="34" charset="-122"/>
                 <a:cs typeface="Be Vietnam Pro" pitchFamily="34" charset="-120"/>
               </a:rPr>
-              <a:t> ký.</a:t>
+              <a:t>thông</a:t>
+            </a:r>
+            <a:r>
+              <a:rPr lang="en-US" sz="2400" dirty="0" spc="5" kern="0">
+                <a:solidFill>
+                  <a:srgbClr val="D8D3C4"/>
+                </a:solidFill>
+                <a:latin typeface="Be Vietnam Pro" pitchFamily="34" charset="0"/>
+                <a:ea typeface="Be Vietnam Pro" pitchFamily="34" charset="-122"/>
+                <a:cs typeface="Be Vietnam Pro" pitchFamily="34" charset="-120"/>
+              </a:rPr>
+              <a:t> thường.</a:t>
             </a:r>
             <a:endParaRPr lang="en-US" sz="2400" dirty="0"/>
           </a:p>
@@ -15237,7 +15257,7 @@
               <a:buNone/>
             </a:pPr>
             <a:r>
-              <a:rPr lang="en-US" sz="7500" dirty="0" spc="0" kern="0">
+              <a:rPr lang="en-US" sz="7500" dirty="0" spc="20" kern="0">
                 <a:solidFill>
                   <a:srgbClr val="F3EEE3"/>
                 </a:solidFill>
@@ -15245,10 +15265,10 @@
                 <a:ea typeface="Bricolage Grotesque ExtraBold" pitchFamily="34" charset="-122"/>
                 <a:cs typeface="Bricolage Grotesque ExtraBold" pitchFamily="34" charset="-120"/>
               </a:rPr>
-              <a:t>Thẻ</a:t>
-            </a:r>
-            <a:r>
-              <a:rPr lang="en-US" sz="7500" dirty="0" spc="-96" kern="0">
+              <a:t>JWT</a:t>
+            </a:r>
+            <a:r>
+              <a:rPr lang="en-US" sz="7500" dirty="0" spc="-1" kern="0">
                 <a:solidFill>
                   <a:srgbClr val="F3EEE3"/>
                 </a:solidFill>
@@ -15256,10 +15276,10 @@
                 <a:ea typeface="Bricolage Grotesque ExtraBold" pitchFamily="34" charset="-122"/>
                 <a:cs typeface="Bricolage Grotesque ExtraBold" pitchFamily="34" charset="-120"/>
               </a:rPr>
-              <a:t> được</a:t>
-            </a:r>
-            <a:r>
-              <a:rPr lang="en-US" sz="7500" dirty="0" spc="-10" kern="0">
+              <a:t> ký</a:t>
+            </a:r>
+            <a:r>
+              <a:rPr lang="en-US" sz="7500" dirty="0" spc="1" kern="0">
                 <a:solidFill>
                   <a:srgbClr val="F3EEE3"/>
                 </a:solidFill>
@@ -15267,10 +15287,10 @@
                 <a:ea typeface="Bricolage Grotesque ExtraBold" pitchFamily="34" charset="-122"/>
                 <a:cs typeface="Bricolage Grotesque ExtraBold" pitchFamily="34" charset="-120"/>
               </a:rPr>
-              <a:t> ký,</a:t>
-            </a:r>
-            <a:r>
-              <a:rPr lang="en-US" sz="7500" dirty="0" spc="1" kern="0">
+              <a:t> thông</a:t>
+            </a:r>
+            <a:r>
+              <a:rPr lang="en-US" sz="7500" dirty="0" spc="-55" kern="0">
                 <a:solidFill>
                   <a:srgbClr val="F3EEE3"/>
                 </a:solidFill>
@@ -15278,10 +15298,10 @@
                 <a:ea typeface="Bricolage Grotesque ExtraBold" pitchFamily="34" charset="-122"/>
                 <a:cs typeface="Bricolage Grotesque ExtraBold" pitchFamily="34" charset="-120"/>
               </a:rPr>
-              <a:t> không</a:t>
-            </a:r>
-            <a:r>
-              <a:rPr lang="en-US" sz="7500" dirty="0" spc="-1" kern="0">
+              <a:t> thường:</a:t>
+            </a:r>
+            <a:r>
+              <a:rPr lang="en-US" sz="7500" dirty="0" spc="1" kern="0">
                 <a:solidFill>
                   <a:srgbClr val="F3EEE3"/>
                 </a:solidFill>
@@ -15289,7 +15309,7 @@
                 <a:ea typeface="Bricolage Grotesque ExtraBold" pitchFamily="34" charset="-122"/>
                 <a:cs typeface="Bricolage Grotesque ExtraBold" pitchFamily="34" charset="-120"/>
               </a:rPr>
-              <a:t> bị</a:t>
+              <a:t> không</a:t>
             </a:r>
             <a:r>
               <a:rPr lang="en-US" sz="7500" dirty="0" spc="2" kern="0">
@@ -15459,11 +15479,11 @@
         <p:spPr>
           <a:xfrm>
             <a:off x="1200150" y="3905250"/>
-            <a:ext cx="7086600" cy="609600"/>
+            <a:ext cx="7086600" cy="476250"/>
           </a:xfrm>
           <a:prstGeom prst="roundRect">
             <a:avLst>
-              <a:gd name="adj" fmla="val 21875"/>
+              <a:gd name="adj" fmla="val 28000"/>
             </a:avLst>
           </a:prstGeom>
           <a:solidFill>
@@ -15481,7 +15501,7 @@
         <p:spPr>
           <a:xfrm>
             <a:off x="1485900" y="3905250"/>
-            <a:ext cx="1524000" cy="609600"/>
+            <a:ext cx="1524000" cy="476250"/>
           </a:xfrm>
           <a:prstGeom prst="rect">
             <a:avLst/>
@@ -15520,7 +15540,7 @@
         <p:spPr>
           <a:xfrm>
             <a:off x="3143250" y="3905250"/>
-            <a:ext cx="4762500" cy="609600"/>
+            <a:ext cx="4762500" cy="476250"/>
           </a:xfrm>
           <a:prstGeom prst="rect">
             <a:avLst/>
@@ -15569,12 +15589,12 @@
         </p:nvSpPr>
         <p:spPr>
           <a:xfrm>
-            <a:off x="1200150" y="4686300"/>
-            <a:ext cx="7086600" cy="609600"/>
+            <a:off x="1200150" y="4476750"/>
+            <a:ext cx="7086600" cy="476250"/>
           </a:xfrm>
           <a:prstGeom prst="roundRect">
             <a:avLst>
-              <a:gd name="adj" fmla="val 21875"/>
+              <a:gd name="adj" fmla="val 28000"/>
             </a:avLst>
           </a:prstGeom>
           <a:solidFill>
@@ -15591,8 +15611,8 @@
         </p:nvSpPr>
         <p:spPr>
           <a:xfrm>
-            <a:off x="1485900" y="4686300"/>
-            <a:ext cx="1524000" cy="609600"/>
+            <a:off x="1485900" y="4476750"/>
+            <a:ext cx="1524000" cy="476250"/>
           </a:xfrm>
           <a:prstGeom prst="rect">
             <a:avLst/>
@@ -15630,8 +15650,8 @@
         </p:nvSpPr>
         <p:spPr>
           <a:xfrm>
-            <a:off x="3143250" y="4686300"/>
-            <a:ext cx="4762500" cy="609600"/>
+            <a:off x="3143250" y="4476750"/>
+            <a:ext cx="4762500" cy="476250"/>
           </a:xfrm>
           <a:prstGeom prst="rect">
             <a:avLst/>
@@ -15680,12 +15700,12 @@
         </p:nvSpPr>
         <p:spPr>
           <a:xfrm>
-            <a:off x="1200150" y="5467350"/>
-            <a:ext cx="7086600" cy="609600"/>
+            <a:off x="1200150" y="5048250"/>
+            <a:ext cx="7086600" cy="476250"/>
           </a:xfrm>
           <a:prstGeom prst="roundRect">
             <a:avLst>
-              <a:gd name="adj" fmla="val 21875"/>
+              <a:gd name="adj" fmla="val 28000"/>
             </a:avLst>
           </a:prstGeom>
           <a:solidFill>
@@ -15702,8 +15722,8 @@
         </p:nvSpPr>
         <p:spPr>
           <a:xfrm>
-            <a:off x="1485900" y="5467350"/>
-            <a:ext cx="1524000" cy="609600"/>
+            <a:off x="1485900" y="5048250"/>
+            <a:ext cx="1524000" cy="476250"/>
           </a:xfrm>
           <a:prstGeom prst="rect">
             <a:avLst/>
@@ -15741,8 +15761,8 @@
         </p:nvSpPr>
         <p:spPr>
           <a:xfrm>
-            <a:off x="3143250" y="5467350"/>
-            <a:ext cx="4762500" cy="609600"/>
+            <a:off x="3143250" y="5048250"/>
+            <a:ext cx="4762500" cy="476250"/>
           </a:xfrm>
           <a:prstGeom prst="rect">
             <a:avLst/>
@@ -15780,12 +15800,12 @@
         </p:nvSpPr>
         <p:spPr>
           <a:xfrm>
-            <a:off x="1200150" y="6381750"/>
-            <a:ext cx="7086600" cy="666750"/>
+            <a:off x="1200150" y="5638800"/>
+            <a:ext cx="7086600" cy="533400"/>
           </a:xfrm>
           <a:prstGeom prst="roundRect">
             <a:avLst>
-              <a:gd name="adj" fmla="val 20000"/>
+              <a:gd name="adj" fmla="val 25000"/>
             </a:avLst>
           </a:prstGeom>
           <a:solidFill>
@@ -15834,7 +15854,7 @@
         </p:nvSpPr>
         <p:spPr>
           <a:xfrm>
-            <a:off x="1295400" y="7353300"/>
+            <a:off x="1295400" y="6362700"/>
             <a:ext cx="6896100" cy="952500"/>
           </a:xfrm>
           <a:prstGeom prst="rect">
@@ -17406,7 +17426,386 @@
       </p:sp>
       <p:sp>
         <p:nvSpPr>
-          <p:cNvPr id="55" name="Shape 53"/>
+          <p:cNvPr id="55" name="Text 53"/>
+          <p:cNvSpPr/>
+          <p:nvPr/>
+        </p:nvSpPr>
+        <p:spPr>
+          <a:xfrm>
+            <a:off x="1295400" y="7391400"/>
+            <a:ext cx="7048500" cy="1104900"/>
+          </a:xfrm>
+          <a:prstGeom prst="rect">
+            <a:avLst/>
+          </a:prstGeom>
+          <a:noFill/>
+          <a:ln/>
+        </p:spPr>
+        <p:txBody>
+          <a:bodyPr wrap="square" lIns="0" tIns="8001" rIns="0" bIns="-8001" rtlCol="0" anchor="t"/>
+          <a:lstStyle/>
+          <a:p>
+            <a:pPr algn="l" indent="0" marL="0">
+              <a:lnSpc>
+                <a:spcPts val="2835"/>
+              </a:lnSpc>
+              <a:buNone/>
+            </a:pPr>
+            <a:r>
+              <a:rPr lang="en-US" sz="2100" dirty="0" spc="-8" kern="0">
+                <a:solidFill>
+                  <a:srgbClr val="F3EEE3"/>
+                </a:solidFill>
+                <a:latin typeface="Be Vietnam Pro SemiBold" pitchFamily="34" charset="0"/>
+                <a:ea typeface="Be Vietnam Pro SemiBold" pitchFamily="34" charset="-122"/>
+                <a:cs typeface="Be Vietnam Pro SemiBold" pitchFamily="34" charset="-120"/>
+              </a:rPr>
+              <a:t>Một</a:t>
+            </a:r>
+            <a:r>
+              <a:rPr lang="en-US" sz="2100" dirty="0" spc="-5" kern="0">
+                <a:solidFill>
+                  <a:srgbClr val="F3EEE3"/>
+                </a:solidFill>
+                <a:latin typeface="Be Vietnam Pro SemiBold" pitchFamily="34" charset="0"/>
+                <a:ea typeface="Be Vietnam Pro SemiBold" pitchFamily="34" charset="-122"/>
+                <a:cs typeface="Be Vietnam Pro SemiBold" pitchFamily="34" charset="-120"/>
+              </a:rPr>
+              <a:t> khóa</a:t>
+            </a:r>
+            <a:r>
+              <a:rPr lang="en-US" sz="2100" dirty="0" spc="-6" kern="0">
+                <a:solidFill>
+                  <a:srgbClr val="F3EEE3"/>
+                </a:solidFill>
+                <a:latin typeface="Be Vietnam Pro SemiBold" pitchFamily="34" charset="0"/>
+                <a:ea typeface="Be Vietnam Pro SemiBold" pitchFamily="34" charset="-122"/>
+                <a:cs typeface="Be Vietnam Pro SemiBold" pitchFamily="34" charset="-120"/>
+              </a:rPr>
+              <a:t> cho</a:t>
+            </a:r>
+            <a:r>
+              <a:rPr lang="en-US" sz="2100" dirty="0" spc="-2" kern="0">
+                <a:solidFill>
+                  <a:srgbClr val="F3EEE3"/>
+                </a:solidFill>
+                <a:latin typeface="Be Vietnam Pro SemiBold" pitchFamily="34" charset="0"/>
+                <a:ea typeface="Be Vietnam Pro SemiBold" pitchFamily="34" charset="-122"/>
+                <a:cs typeface="Be Vietnam Pro SemiBold" pitchFamily="34" charset="-120"/>
+              </a:rPr>
+              <a:t> nhiều</a:t>
+            </a:r>
+            <a:r>
+              <a:rPr lang="en-US" sz="2100" dirty="0" spc="-4" kern="0">
+                <a:solidFill>
+                  <a:srgbClr val="F3EEE3"/>
+                </a:solidFill>
+                <a:latin typeface="Be Vietnam Pro SemiBold" pitchFamily="34" charset="0"/>
+                <a:ea typeface="Be Vietnam Pro SemiBold" pitchFamily="34" charset="-122"/>
+                <a:cs typeface="Be Vietnam Pro SemiBold" pitchFamily="34" charset="-120"/>
+              </a:rPr>
+              <a:t> bên:</a:t>
+            </a:r>
+            <a:r>
+              <a:rPr lang="en-US" sz="2100" dirty="0" spc="0" kern="0">
+                <a:solidFill>
+                  <a:srgbClr val="F3EEE3"/>
+                </a:solidFill>
+                <a:latin typeface="Be Vietnam Pro SemiBold" pitchFamily="34" charset="0"/>
+                <a:ea typeface="Be Vietnam Pro SemiBold" pitchFamily="34" charset="-122"/>
+                <a:cs typeface="Be Vietnam Pro SemiBold" pitchFamily="34" charset="-120"/>
+              </a:rPr>
+              <a:t> kiểm</a:t>
+            </a:r>
+            <a:r>
+              <a:rPr lang="en-US" sz="2100" dirty="0" spc="-6" kern="0">
+                <a:solidFill>
+                  <a:srgbClr val="F3EEE3"/>
+                </a:solidFill>
+                <a:latin typeface="Be Vietnam Pro SemiBold" pitchFamily="34" charset="0"/>
+                <a:ea typeface="Be Vietnam Pro SemiBold" pitchFamily="34" charset="-122"/>
+                <a:cs typeface="Be Vietnam Pro SemiBold" pitchFamily="34" charset="-120"/>
+              </a:rPr>
+              <a:t> cả</a:t>
+            </a:r>
+            <a:r>
+              <a:rPr lang="en-US" sz="2100" dirty="0" spc="-7" kern="0">
+                <a:solidFill>
+                  <a:srgbClr val="F3EEE3"/>
+                </a:solidFill>
+                <a:latin typeface="Be Vietnam Pro SemiBold" pitchFamily="34" charset="0"/>
+                <a:ea typeface="Be Vietnam Pro SemiBold" pitchFamily="34" charset="-122"/>
+                <a:cs typeface="Be Vietnam Pro SemiBold" pitchFamily="34" charset="-120"/>
+              </a:rPr>
+              <a:t> iss</a:t>
+            </a:r>
+            <a:r>
+              <a:rPr lang="en-US" sz="2100" dirty="0" spc="-19" kern="0">
+                <a:solidFill>
+                  <a:srgbClr val="F3EEE3"/>
+                </a:solidFill>
+                <a:latin typeface="Be Vietnam Pro SemiBold" pitchFamily="34" charset="0"/>
+                <a:ea typeface="Be Vietnam Pro SemiBold" pitchFamily="34" charset="-122"/>
+                <a:cs typeface="Be Vietnam Pro SemiBold" pitchFamily="34" charset="-120"/>
+              </a:rPr>
+              <a:t> và</a:t>
+            </a:r>
+            <a:r>
+              <a:rPr lang="en-US" sz="2100" dirty="0" spc="-2" kern="0">
+                <a:solidFill>
+                  <a:srgbClr val="F3EEE3"/>
+                </a:solidFill>
+                <a:latin typeface="Be Vietnam Pro SemiBold" pitchFamily="34" charset="0"/>
+                <a:ea typeface="Be Vietnam Pro SemiBold" pitchFamily="34" charset="-122"/>
+                <a:cs typeface="Be Vietnam Pro SemiBold" pitchFamily="34" charset="-120"/>
+              </a:rPr>
+              <a:t> aud.</a:t>
+            </a:r>
+            <a:endParaRPr lang="en-US" sz="2100" dirty="0"/>
+          </a:p>
+          <a:p>
+            <a:pPr algn="l" indent="0" marL="0">
+              <a:lnSpc>
+                <a:spcPts val="2835"/>
+              </a:lnSpc>
+              <a:buNone/>
+            </a:pPr>
+            <a:r>
+              <a:rPr lang="en-US" sz="2100" dirty="0" spc="3" kern="0">
+                <a:solidFill>
+                  <a:srgbClr val="9A98A0"/>
+                </a:solidFill>
+                <a:latin typeface="Be Vietnam Pro" pitchFamily="34" charset="0"/>
+                <a:ea typeface="Be Vietnam Pro" pitchFamily="34" charset="-122"/>
+                <a:cs typeface="Be Vietnam Pro" pitchFamily="34" charset="-120"/>
+              </a:rPr>
+              <a:t>iss:</a:t>
+            </a:r>
+            <a:r>
+              <a:rPr lang="en-US" sz="2100" dirty="0" spc="-3" kern="0">
+                <a:solidFill>
+                  <a:srgbClr val="9A98A0"/>
+                </a:solidFill>
+                <a:latin typeface="Be Vietnam Pro" pitchFamily="34" charset="0"/>
+                <a:ea typeface="Be Vietnam Pro" pitchFamily="34" charset="-122"/>
+                <a:cs typeface="Be Vietnam Pro" pitchFamily="34" charset="-120"/>
+              </a:rPr>
+              <a:t> bên</a:t>
+            </a:r>
+            <a:r>
+              <a:rPr lang="en-US" sz="2100" dirty="0" spc="-12" kern="0">
+                <a:solidFill>
+                  <a:srgbClr val="9A98A0"/>
+                </a:solidFill>
+                <a:latin typeface="Be Vietnam Pro" pitchFamily="34" charset="0"/>
+                <a:ea typeface="Be Vietnam Pro" pitchFamily="34" charset="-122"/>
+                <a:cs typeface="Be Vietnam Pro" pitchFamily="34" charset="-120"/>
+              </a:rPr>
+              <a:t> phát</a:t>
+            </a:r>
+            <a:r>
+              <a:rPr lang="en-US" sz="2100" dirty="0" spc="0" kern="0">
+                <a:solidFill>
+                  <a:srgbClr val="9A98A0"/>
+                </a:solidFill>
+                <a:latin typeface="Be Vietnam Pro" pitchFamily="34" charset="0"/>
+                <a:ea typeface="Be Vietnam Pro" pitchFamily="34" charset="-122"/>
+                <a:cs typeface="Be Vietnam Pro" pitchFamily="34" charset="-120"/>
+              </a:rPr>
+              <a:t> mong</a:t>
+            </a:r>
+            <a:r>
+              <a:rPr lang="en-US" sz="2100" dirty="0" spc="7" kern="0">
+                <a:solidFill>
+                  <a:srgbClr val="9A98A0"/>
+                </a:solidFill>
+                <a:latin typeface="Be Vietnam Pro" pitchFamily="34" charset="0"/>
+                <a:ea typeface="Be Vietnam Pro" pitchFamily="34" charset="-122"/>
+                <a:cs typeface="Be Vietnam Pro" pitchFamily="34" charset="-120"/>
+              </a:rPr>
+              <a:t> đợi,</a:t>
+            </a:r>
+            <a:r>
+              <a:rPr lang="en-US" sz="2100" dirty="0" spc="-2" kern="0">
+                <a:solidFill>
+                  <a:srgbClr val="9A98A0"/>
+                </a:solidFill>
+                <a:latin typeface="Be Vietnam Pro" pitchFamily="34" charset="0"/>
+                <a:ea typeface="Be Vietnam Pro" pitchFamily="34" charset="-122"/>
+                <a:cs typeface="Be Vietnam Pro" pitchFamily="34" charset="-120"/>
+              </a:rPr>
+              <a:t> aud:</a:t>
+            </a:r>
+            <a:r>
+              <a:rPr lang="en-US" sz="2100" dirty="0" spc="-3" kern="0">
+                <a:solidFill>
+                  <a:srgbClr val="9A98A0"/>
+                </a:solidFill>
+                <a:latin typeface="Be Vietnam Pro" pitchFamily="34" charset="0"/>
+                <a:ea typeface="Be Vietnam Pro" pitchFamily="34" charset="-122"/>
+                <a:cs typeface="Be Vietnam Pro" pitchFamily="34" charset="-120"/>
+              </a:rPr>
+              <a:t> bên</a:t>
+            </a:r>
+            <a:r>
+              <a:rPr lang="en-US" sz="2100" dirty="0" spc="0" kern="0">
+                <a:solidFill>
+                  <a:srgbClr val="9A98A0"/>
+                </a:solidFill>
+                <a:latin typeface="Be Vietnam Pro" pitchFamily="34" charset="0"/>
+                <a:ea typeface="Be Vietnam Pro" pitchFamily="34" charset="-122"/>
+                <a:cs typeface="Be Vietnam Pro" pitchFamily="34" charset="-120"/>
+              </a:rPr>
+              <a:t> nhận</a:t>
+            </a:r>
+            <a:r>
+              <a:rPr lang="en-US" sz="2100" dirty="0" spc="-1" kern="0">
+                <a:solidFill>
+                  <a:srgbClr val="9A98A0"/>
+                </a:solidFill>
+                <a:latin typeface="Be Vietnam Pro" pitchFamily="34" charset="0"/>
+                <a:ea typeface="Be Vietnam Pro" pitchFamily="34" charset="-122"/>
+                <a:cs typeface="Be Vietnam Pro" pitchFamily="34" charset="-120"/>
+              </a:rPr>
+              <a:t> mong</a:t>
+            </a:r>
+            <a:r>
+              <a:rPr lang="en-US" sz="2100" dirty="0" spc="8" kern="0">
+                <a:solidFill>
+                  <a:srgbClr val="9A98A0"/>
+                </a:solidFill>
+                <a:latin typeface="Be Vietnam Pro" pitchFamily="34" charset="0"/>
+                <a:ea typeface="Be Vietnam Pro" pitchFamily="34" charset="-122"/>
+                <a:cs typeface="Be Vietnam Pro" pitchFamily="34" charset="-120"/>
+              </a:rPr>
+              <a:t> đợi.</a:t>
+            </a:r>
+            <a:endParaRPr lang="en-US" sz="2100" dirty="0"/>
+          </a:p>
+          <a:p>
+            <a:pPr algn="l" indent="0" marL="0">
+              <a:lnSpc>
+                <a:spcPts val="2835"/>
+              </a:lnSpc>
+              <a:buNone/>
+            </a:pPr>
+            <a:r>
+              <a:rPr lang="en-US" sz="2100" dirty="0" spc="15" kern="0">
+                <a:solidFill>
+                  <a:srgbClr val="9A98A0"/>
+                </a:solidFill>
+                <a:latin typeface="Be Vietnam Pro" pitchFamily="34" charset="0"/>
+                <a:ea typeface="Be Vietnam Pro" pitchFamily="34" charset="-122"/>
+                <a:cs typeface="Be Vietnam Pro" pitchFamily="34" charset="-120"/>
+              </a:rPr>
+              <a:t>JWT</a:t>
+            </a:r>
+            <a:r>
+              <a:rPr lang="en-US" sz="2100" dirty="0" spc="-3" kern="0">
+                <a:solidFill>
+                  <a:srgbClr val="9A98A0"/>
+                </a:solidFill>
+                <a:latin typeface="Be Vietnam Pro" pitchFamily="34" charset="0"/>
+                <a:ea typeface="Be Vietnam Pro" pitchFamily="34" charset="-122"/>
+                <a:cs typeface="Be Vietnam Pro" pitchFamily="34" charset="-120"/>
+              </a:rPr>
+              <a:t> mã</a:t>
+            </a:r>
+            <a:r>
+              <a:rPr lang="en-US" sz="2100" dirty="0" spc="-6" kern="0">
+                <a:solidFill>
+                  <a:srgbClr val="9A98A0"/>
+                </a:solidFill>
+                <a:latin typeface="Be Vietnam Pro" pitchFamily="34" charset="0"/>
+                <a:ea typeface="Be Vietnam Pro" pitchFamily="34" charset="-122"/>
+                <a:cs typeface="Be Vietnam Pro" pitchFamily="34" charset="-120"/>
+              </a:rPr>
+              <a:t> hóa</a:t>
+            </a:r>
+            <a:r>
+              <a:rPr lang="en-US" sz="2100" dirty="0" spc="8" kern="0">
+                <a:solidFill>
+                  <a:srgbClr val="9A98A0"/>
+                </a:solidFill>
+                <a:latin typeface="Be Vietnam Pro" pitchFamily="34" charset="0"/>
+                <a:ea typeface="Be Vietnam Pro" pitchFamily="34" charset="-122"/>
+                <a:cs typeface="Be Vietnam Pro" pitchFamily="34" charset="-120"/>
+              </a:rPr>
+              <a:t> riêng</a:t>
+            </a:r>
+            <a:r>
+              <a:rPr lang="en-US" sz="2100" dirty="0" spc="-3" kern="0">
+                <a:solidFill>
+                  <a:srgbClr val="9A98A0"/>
+                </a:solidFill>
+                <a:latin typeface="Be Vietnam Pro" pitchFamily="34" charset="0"/>
+                <a:ea typeface="Be Vietnam Pro" pitchFamily="34" charset="-122"/>
+                <a:cs typeface="Be Vietnam Pro" pitchFamily="34" charset="-120"/>
+              </a:rPr>
+              <a:t> là</a:t>
+            </a:r>
+            <a:r>
+              <a:rPr lang="en-US" sz="2100" dirty="0" spc="-2" kern="0">
+                <a:solidFill>
+                  <a:srgbClr val="9A98A0"/>
+                </a:solidFill>
+                <a:latin typeface="Be Vietnam Pro" pitchFamily="34" charset="0"/>
+                <a:ea typeface="Be Vietnam Pro" pitchFamily="34" charset="-122"/>
+                <a:cs typeface="Be Vietnam Pro" pitchFamily="34" charset="-120"/>
+              </a:rPr>
+              <a:t> dạng</a:t>
+            </a:r>
+            <a:r>
+              <a:rPr lang="en-US" sz="2100" dirty="0" spc="-1" kern="0">
+                <a:solidFill>
+                  <a:srgbClr val="9A98A0"/>
+                </a:solidFill>
+                <a:latin typeface="Be Vietnam Pro" pitchFamily="34" charset="0"/>
+                <a:ea typeface="Be Vietnam Pro" pitchFamily="34" charset="-122"/>
+                <a:cs typeface="Be Vietnam Pro" pitchFamily="34" charset="-120"/>
+              </a:rPr>
+              <a:t> khác,</a:t>
+            </a:r>
+            <a:r>
+              <a:rPr lang="en-US" sz="2100" dirty="0" spc="-6" kern="0">
+                <a:solidFill>
+                  <a:srgbClr val="9A98A0"/>
+                </a:solidFill>
+                <a:latin typeface="Be Vietnam Pro" pitchFamily="34" charset="0"/>
+                <a:ea typeface="Be Vietnam Pro" pitchFamily="34" charset="-122"/>
+                <a:cs typeface="Be Vietnam Pro" pitchFamily="34" charset="-120"/>
+              </a:rPr>
+              <a:t> bài</a:t>
+            </a:r>
+            <a:r>
+              <a:rPr lang="en-US" sz="2100" dirty="0" spc="0" kern="0">
+                <a:solidFill>
+                  <a:srgbClr val="9A98A0"/>
+                </a:solidFill>
+                <a:latin typeface="Be Vietnam Pro" pitchFamily="34" charset="0"/>
+                <a:ea typeface="Be Vietnam Pro" pitchFamily="34" charset="-122"/>
+                <a:cs typeface="Be Vietnam Pro" pitchFamily="34" charset="-120"/>
+              </a:rPr>
+              <a:t> không</a:t>
+            </a:r>
+            <a:r>
+              <a:rPr lang="en-US" sz="2100" dirty="0" spc="-5" kern="0">
+                <a:solidFill>
+                  <a:srgbClr val="9A98A0"/>
+                </a:solidFill>
+                <a:latin typeface="Be Vietnam Pro" pitchFamily="34" charset="0"/>
+                <a:ea typeface="Be Vietnam Pro" pitchFamily="34" charset="-122"/>
+                <a:cs typeface="Be Vietnam Pro" pitchFamily="34" charset="-120"/>
+              </a:rPr>
+              <a:t> bàn.</a:t>
+            </a:r>
+            <a:endParaRPr lang="en-US" sz="2100" dirty="0"/>
+          </a:p>
+        </p:txBody>
+      </p:sp>
+      <p:sp>
+        <p:nvSpPr>
+          <p:cNvPr id="56" name="Shape 54"/>
           <p:cNvSpPr/>
           <p:nvPr/>
         </p:nvSpPr>
@@ -17430,7 +17829,7 @@
       </p:sp>
       <p:pic>
         <p:nvPicPr>
-          <p:cNvPr id="56" name="Moda image moda-export-watermark-488b74cd-3a24-40d4-8d49-d0d83385ec9c" descr="">    </p:cNvPr>
+          <p:cNvPr id="57" name="Moda image moda-export-watermark-488b74cd-3a24-40d4-8d49-d0d83385ec9c" descr="">    </p:cNvPr>
           <p:cNvPicPr>
             <a:picLocks noChangeAspect="1"/>
           </p:cNvPicPr>
@@ -18599,6 +18998,72 @@
               <a:t> trình,</a:t>
             </a:r>
             <a:r>
+              <a:rPr lang="en-US" sz="2550" dirty="0" spc="-5" kern="0">
+                <a:solidFill>
+                  <a:srgbClr val="14161C"/>
+                </a:solidFill>
+                <a:latin typeface="Be Vietnam Pro" pitchFamily="34" charset="0"/>
+                <a:ea typeface="Be Vietnam Pro" pitchFamily="34" charset="-122"/>
+                <a:cs typeface="Be Vietnam Pro" pitchFamily="34" charset="-120"/>
+              </a:rPr>
+              <a:t> một</a:t>
+            </a:r>
+            <a:r>
+              <a:rPr lang="en-US" sz="2550" dirty="0" spc="-8" kern="0">
+                <a:solidFill>
+                  <a:srgbClr val="14161C"/>
+                </a:solidFill>
+                <a:latin typeface="Be Vietnam Pro" pitchFamily="34" charset="0"/>
+                <a:ea typeface="Be Vietnam Pro" pitchFamily="34" charset="-122"/>
+                <a:cs typeface="Be Vietnam Pro" pitchFamily="34" charset="-120"/>
+              </a:rPr>
+              <a:t> máy</a:t>
+            </a:r>
+            <a:r>
+              <a:rPr lang="en-US" sz="2550" dirty="0" spc="-2" kern="0">
+                <a:solidFill>
+                  <a:srgbClr val="14161C"/>
+                </a:solidFill>
+                <a:latin typeface="Be Vietnam Pro" pitchFamily="34" charset="0"/>
+                <a:ea typeface="Be Vietnam Pro" pitchFamily="34" charset="-122"/>
+                <a:cs typeface="Be Vietnam Pro" pitchFamily="34" charset="-120"/>
+              </a:rPr>
+              <a:t> chủ</a:t>
+            </a:r>
+            <a:r>
+              <a:rPr lang="en-US" sz="2550" dirty="0" spc="6" kern="0">
+                <a:solidFill>
+                  <a:srgbClr val="14161C"/>
+                </a:solidFill>
+                <a:latin typeface="Be Vietnam Pro" pitchFamily="34" charset="0"/>
+                <a:ea typeface="Be Vietnam Pro" pitchFamily="34" charset="-122"/>
+                <a:cs typeface="Be Vietnam Pro" pitchFamily="34" charset="-120"/>
+              </a:rPr>
+              <a:t> vừa</a:t>
+            </a:r>
+            <a:r>
+              <a:rPr lang="en-US" sz="2550" dirty="0" spc="-9" kern="0">
+                <a:solidFill>
+                  <a:srgbClr val="14161C"/>
+                </a:solidFill>
+                <a:latin typeface="Be Vietnam Pro" pitchFamily="34" charset="0"/>
+                <a:ea typeface="Be Vietnam Pro" pitchFamily="34" charset="-122"/>
+                <a:cs typeface="Be Vietnam Pro" pitchFamily="34" charset="-120"/>
+              </a:rPr>
+              <a:t> phát</a:t>
+            </a:r>
+            <a:r>
+              <a:rPr lang="en-US" sz="2550" dirty="0" spc="6" kern="0">
+                <a:solidFill>
+                  <a:srgbClr val="14161C"/>
+                </a:solidFill>
+                <a:latin typeface="Be Vietnam Pro" pitchFamily="34" charset="0"/>
+                <a:ea typeface="Be Vietnam Pro" pitchFamily="34" charset="-122"/>
+                <a:cs typeface="Be Vietnam Pro" pitchFamily="34" charset="-120"/>
+              </a:rPr>
+              <a:t> vừa</a:t>
+            </a:r>
+            <a:r>
               <a:rPr lang="en-US" sz="2550" dirty="0" spc="1" kern="0">
                 <a:solidFill>
                   <a:srgbClr val="14161C"/>
@@ -18607,7 +19072,18 @@
                 <a:ea typeface="Be Vietnam Pro" pitchFamily="34" charset="-122"/>
                 <a:cs typeface="Be Vietnam Pro" pitchFamily="34" charset="-120"/>
               </a:rPr>
-              <a:t> không</a:t>
+              <a:t> kiểm</a:t>
+            </a:r>
+            <a:r>
+              <a:rPr lang="en-US" sz="2550" dirty="0" spc="11" kern="0">
+                <a:solidFill>
+                  <a:srgbClr val="14161C"/>
+                </a:solidFill>
+                <a:latin typeface="Be Vietnam Pro" pitchFamily="34" charset="0"/>
+                <a:ea typeface="Be Vietnam Pro" pitchFamily="34" charset="-122"/>
+                <a:cs typeface="Be Vietnam Pro" pitchFamily="34" charset="-120"/>
+              </a:rPr>
+              <a:t> JWT</a:t>
             </a:r>
             <a:r>
               <a:rPr lang="en-US" sz="2550" dirty="0" spc="0" kern="0">
@@ -18618,29 +19094,7 @@
                 <a:ea typeface="Be Vietnam Pro" pitchFamily="34" charset="-122"/>
                 <a:cs typeface="Be Vietnam Pro" pitchFamily="34" charset="-120"/>
               </a:rPr>
-              <a:t> nhiều</a:t>
-            </a:r>
-            <a:r>
-              <a:rPr lang="en-US" sz="2550" dirty="0" spc="-8" kern="0">
-                <a:solidFill>
-                  <a:srgbClr val="14161C"/>
-                </a:solidFill>
-                <a:latin typeface="Be Vietnam Pro" pitchFamily="34" charset="0"/>
-                <a:ea typeface="Be Vietnam Pro" pitchFamily="34" charset="-122"/>
-                <a:cs typeface="Be Vietnam Pro" pitchFamily="34" charset="-120"/>
-              </a:rPr>
-              <a:t> máy</a:t>
-            </a:r>
-            <a:r>
-              <a:rPr lang="en-US" sz="2550" dirty="0" spc="-2" kern="0">
-                <a:solidFill>
-                  <a:srgbClr val="14161C"/>
-                </a:solidFill>
-                <a:latin typeface="Be Vietnam Pro" pitchFamily="34" charset="0"/>
-                <a:ea typeface="Be Vietnam Pro" pitchFamily="34" charset="-122"/>
-                <a:cs typeface="Be Vietnam Pro" pitchFamily="34" charset="-120"/>
-              </a:rPr>
-              <a:t> chủ,</a:t>
+              <a:t> ký,</a:t>
             </a:r>
             <a:endParaRPr lang="en-US" sz="2550" dirty="0"/>
           </a:p>
@@ -18663,7 +19117,51 @@
               <a:t>không</a:t>
             </a:r>
             <a:r>
-              <a:rPr lang="en-US" sz="2550" dirty="0" spc="16" kern="0">
+              <a:rPr lang="en-US" sz="2550" dirty="0" spc="0" kern="0">
+                <a:solidFill>
+                  <a:srgbClr val="14161C"/>
+                </a:solidFill>
+                <a:latin typeface="Be Vietnam Pro" pitchFamily="34" charset="0"/>
+                <a:ea typeface="Be Vietnam Pro" pitchFamily="34" charset="-122"/>
+                <a:cs typeface="Be Vietnam Pro" pitchFamily="34" charset="-120"/>
+              </a:rPr>
+              <a:t> nhiều</a:t>
+            </a:r>
+            <a:r>
+              <a:rPr lang="en-US" sz="2550" dirty="0" spc="-8" kern="0">
+                <a:solidFill>
+                  <a:srgbClr val="14161C"/>
+                </a:solidFill>
+                <a:latin typeface="Be Vietnam Pro" pitchFamily="34" charset="0"/>
+                <a:ea typeface="Be Vietnam Pro" pitchFamily="34" charset="-122"/>
+                <a:cs typeface="Be Vietnam Pro" pitchFamily="34" charset="-120"/>
+              </a:rPr>
+              <a:t> máy</a:t>
+            </a:r>
+            <a:r>
+              <a:rPr lang="en-US" sz="2550" dirty="0" spc="-2" kern="0">
+                <a:solidFill>
+                  <a:srgbClr val="14161C"/>
+                </a:solidFill>
+                <a:latin typeface="Be Vietnam Pro" pitchFamily="34" charset="0"/>
+                <a:ea typeface="Be Vietnam Pro" pitchFamily="34" charset="-122"/>
+                <a:cs typeface="Be Vietnam Pro" pitchFamily="34" charset="-120"/>
+              </a:rPr>
+              <a:t> chủ,</a:t>
+            </a:r>
+            <a:r>
+              <a:rPr lang="en-US" sz="2550" dirty="0" spc="0" kern="0">
+                <a:solidFill>
+                  <a:srgbClr val="14161C"/>
+                </a:solidFill>
+                <a:latin typeface="Be Vietnam Pro" pitchFamily="34" charset="0"/>
+                <a:ea typeface="Be Vietnam Pro" pitchFamily="34" charset="-122"/>
+                <a:cs typeface="Be Vietnam Pro" pitchFamily="34" charset="-120"/>
+              </a:rPr>
+              <a:t> không</a:t>
+            </a:r>
+            <a:r>
+              <a:rPr lang="en-US" sz="2550" dirty="0" spc="17" kern="0">
                 <a:solidFill>
                   <a:srgbClr val="14161C"/>
                 </a:solidFill>

</xml_diff>